<commit_message>
Pitch deck v2: 7-section image-forward redesign (ClawComp × Link Ventures)
Cut 13→7 big sections, less text. New product logos (Studio spectrum-S, Forge
anvil+star, Archie wordmark), real Studio renders, GitHub/Vercel business model,
and an embedded demo video on slide 4. v13 archived locally.

Co-Authored-By: Claude Opus 4.8 (1M context) <noreply@anthropic.com>
</commit_message>
<xml_diff>
--- a/pitch-deck/out/ArchDisc-LinkVentures.pptx
+++ b/pitch-deck/out/ArchDisc-LinkVentures.pptx
@@ -12,12 +12,6 @@
     <p:sldId id="260" r:id="rId11"/>
     <p:sldId id="261" r:id="rId12"/>
     <p:sldId id="262" r:id="rId13"/>
-    <p:sldId id="263" r:id="rId14"/>
-    <p:sldId id="264" r:id="rId15"/>
-    <p:sldId id="265" r:id="rId16"/>
-    <p:sldId id="266" r:id="rId17"/>
-    <p:sldId id="267" r:id="rId18"/>
-    <p:sldId id="268" r:id="rId19"/>
   </p:sldIdLst>
   <p:sldSz cx="12192000" cy="6858000" type="screen4x3"/>
   <p:notesSz cx="6858000" cy="9144000"/>
@@ -3132,174 +3126,6 @@
 </p:sld>
 </file>
 
-<file path=ppt/slides/slide10.xml><?xml version="1.0" encoding="utf-8"?>
-<p:sld xmlns:a="http://schemas.openxmlformats.org/drawingml/2006/main" xmlns:p="http://schemas.openxmlformats.org/presentationml/2006/main" xmlns:r="http://schemas.openxmlformats.org/officeDocument/2006/relationships">
-  <p:cSld>
-    <p:spTree>
-      <p:nvGrpSpPr>
-        <p:cNvPr id="1" name=""/>
-        <p:cNvGrpSpPr/>
-        <p:nvPr/>
-      </p:nvGrpSpPr>
-      <p:grpSpPr/>
-      <p:pic>
-        <p:nvPicPr>
-          <p:cNvPr id="2" name="Picture 1" descr="10-model.png"/>
-          <p:cNvPicPr>
-            <a:picLocks noChangeAspect="1"/>
-          </p:cNvPicPr>
-          <p:nvPr/>
-        </p:nvPicPr>
-        <p:blipFill>
-          <a:blip r:embed="rId2"/>
-          <a:stretch>
-            <a:fillRect/>
-          </a:stretch>
-        </p:blipFill>
-        <p:spPr>
-          <a:xfrm>
-            <a:off x="0" y="0"/>
-            <a:ext cx="12192000" cy="6858000"/>
-          </a:xfrm>
-          <a:prstGeom prst="rect">
-            <a:avLst/>
-          </a:prstGeom>
-        </p:spPr>
-      </p:pic>
-    </p:spTree>
-  </p:cSld>
-  <p:clrMapOvr>
-    <a:masterClrMapping/>
-  </p:clrMapOvr>
-</p:sld>
-</file>
-
-<file path=ppt/slides/slide11.xml><?xml version="1.0" encoding="utf-8"?>
-<p:sld xmlns:a="http://schemas.openxmlformats.org/drawingml/2006/main" xmlns:p="http://schemas.openxmlformats.org/presentationml/2006/main" xmlns:r="http://schemas.openxmlformats.org/officeDocument/2006/relationships">
-  <p:cSld>
-    <p:spTree>
-      <p:nvGrpSpPr>
-        <p:cNvPr id="1" name=""/>
-        <p:cNvGrpSpPr/>
-        <p:nvPr/>
-      </p:nvGrpSpPr>
-      <p:grpSpPr/>
-      <p:pic>
-        <p:nvPicPr>
-          <p:cNvPr id="2" name="Picture 1" descr="11-traction.png"/>
-          <p:cNvPicPr>
-            <a:picLocks noChangeAspect="1"/>
-          </p:cNvPicPr>
-          <p:nvPr/>
-        </p:nvPicPr>
-        <p:blipFill>
-          <a:blip r:embed="rId2"/>
-          <a:stretch>
-            <a:fillRect/>
-          </a:stretch>
-        </p:blipFill>
-        <p:spPr>
-          <a:xfrm>
-            <a:off x="0" y="0"/>
-            <a:ext cx="12192000" cy="6858000"/>
-          </a:xfrm>
-          <a:prstGeom prst="rect">
-            <a:avLst/>
-          </a:prstGeom>
-        </p:spPr>
-      </p:pic>
-    </p:spTree>
-  </p:cSld>
-  <p:clrMapOvr>
-    <a:masterClrMapping/>
-  </p:clrMapOvr>
-</p:sld>
-</file>
-
-<file path=ppt/slides/slide12.xml><?xml version="1.0" encoding="utf-8"?>
-<p:sld xmlns:a="http://schemas.openxmlformats.org/drawingml/2006/main" xmlns:p="http://schemas.openxmlformats.org/presentationml/2006/main" xmlns:r="http://schemas.openxmlformats.org/officeDocument/2006/relationships">
-  <p:cSld>
-    <p:spTree>
-      <p:nvGrpSpPr>
-        <p:cNvPr id="1" name=""/>
-        <p:cNvGrpSpPr/>
-        <p:nvPr/>
-      </p:nvGrpSpPr>
-      <p:grpSpPr/>
-      <p:pic>
-        <p:nvPicPr>
-          <p:cNvPr id="2" name="Picture 1" descr="12-team.png"/>
-          <p:cNvPicPr>
-            <a:picLocks noChangeAspect="1"/>
-          </p:cNvPicPr>
-          <p:nvPr/>
-        </p:nvPicPr>
-        <p:blipFill>
-          <a:blip r:embed="rId2"/>
-          <a:stretch>
-            <a:fillRect/>
-          </a:stretch>
-        </p:blipFill>
-        <p:spPr>
-          <a:xfrm>
-            <a:off x="0" y="0"/>
-            <a:ext cx="12192000" cy="6858000"/>
-          </a:xfrm>
-          <a:prstGeom prst="rect">
-            <a:avLst/>
-          </a:prstGeom>
-        </p:spPr>
-      </p:pic>
-    </p:spTree>
-  </p:cSld>
-  <p:clrMapOvr>
-    <a:masterClrMapping/>
-  </p:clrMapOvr>
-</p:sld>
-</file>
-
-<file path=ppt/slides/slide13.xml><?xml version="1.0" encoding="utf-8"?>
-<p:sld xmlns:a="http://schemas.openxmlformats.org/drawingml/2006/main" xmlns:p="http://schemas.openxmlformats.org/presentationml/2006/main" xmlns:r="http://schemas.openxmlformats.org/officeDocument/2006/relationships">
-  <p:cSld>
-    <p:spTree>
-      <p:nvGrpSpPr>
-        <p:cNvPr id="1" name=""/>
-        <p:cNvGrpSpPr/>
-        <p:nvPr/>
-      </p:nvGrpSpPr>
-      <p:grpSpPr/>
-      <p:pic>
-        <p:nvPicPr>
-          <p:cNvPr id="2" name="Picture 1" descr="13-ask.png"/>
-          <p:cNvPicPr>
-            <a:picLocks noChangeAspect="1"/>
-          </p:cNvPicPr>
-          <p:nvPr/>
-        </p:nvPicPr>
-        <p:blipFill>
-          <a:blip r:embed="rId2"/>
-          <a:stretch>
-            <a:fillRect/>
-          </a:stretch>
-        </p:blipFill>
-        <p:spPr>
-          <a:xfrm>
-            <a:off x="0" y="0"/>
-            <a:ext cx="12192000" cy="6858000"/>
-          </a:xfrm>
-          <a:prstGeom prst="rect">
-            <a:avLst/>
-          </a:prstGeom>
-        </p:spPr>
-      </p:pic>
-    </p:spTree>
-  </p:cSld>
-  <p:clrMapOvr>
-    <a:masterClrMapping/>
-  </p:clrMapOvr>
-</p:sld>
-</file>
-
 <file path=ppt/slides/slide2.xml><?xml version="1.0" encoding="utf-8"?>
 <p:sld xmlns:a="http://schemas.openxmlformats.org/drawingml/2006/main" xmlns:p="http://schemas.openxmlformats.org/presentationml/2006/main" xmlns:r="http://schemas.openxmlformats.org/officeDocument/2006/relationships">
   <p:cSld>
@@ -3354,7 +3180,7 @@
       <p:grpSpPr/>
       <p:pic>
         <p:nvPicPr>
-          <p:cNvPr id="2" name="Picture 1" descr="03-why.png"/>
+          <p:cNvPr id="2" name="Picture 1" descr="03-platform.png"/>
           <p:cNvPicPr>
             <a:picLocks noChangeAspect="1"/>
           </p:cNvPicPr>
@@ -3396,7 +3222,7 @@
       <p:grpSpPr/>
       <p:pic>
         <p:nvPicPr>
-          <p:cNvPr id="2" name="Picture 1" descr="04-market.png"/>
+          <p:cNvPr id="2" name="Picture 1" descr="04-demo.png"/>
           <p:cNvPicPr>
             <a:picLocks noChangeAspect="1"/>
           </p:cNvPicPr>
@@ -3418,11 +3244,66 @@
           </a:prstGeom>
         </p:spPr>
       </p:pic>
+      <p:pic>
+        <p:nvPicPr>
+          <p:cNvPr id="3" name="demo.mp4">
+            <a:hlinkClick r:id="" action="ppaction://media"/>
+          </p:cNvPr>
+          <p:cNvPicPr>
+            <a:picLocks noChangeAspect="1"/>
+          </p:cNvPicPr>
+          <p:nvPr>
+            <a:videoFile r:link="rId4"/>
+            <p:extLst>
+              <p:ext uri="{DAA4B4D4-6D71-4841-9C94-3DE7FCFB9230}">
+                <p14:media xmlns:p14="http://schemas.microsoft.com/office/powerpoint/2010/main" r:embed="rId3"/>
+              </p:ext>
+            </p:extLst>
+          </p:nvPr>
+        </p:nvPicPr>
+        <p:blipFill>
+          <a:blip r:embed="rId5"/>
+          <a:stretch>
+            <a:fillRect/>
+          </a:stretch>
+        </p:blipFill>
+        <p:spPr>
+          <a:xfrm>
+            <a:off x="2476500" y="1809750"/>
+            <a:ext cx="7239000" cy="4076700"/>
+          </a:xfrm>
+          <a:prstGeom prst="rect">
+            <a:avLst/>
+          </a:prstGeom>
+        </p:spPr>
+      </p:pic>
     </p:spTree>
   </p:cSld>
   <p:clrMapOvr>
     <a:masterClrMapping/>
   </p:clrMapOvr>
+  <p:timing>
+    <p:tnLst>
+      <p:par>
+        <p:cTn id="1" dur="indefinite" restart="never" nodeType="tmRoot">
+          <p:childTnLst>
+            <p:video>
+              <p:cMediaNode vol="80000">
+                <p:cTn id="2" fill="hold" display="0">
+                  <p:stCondLst>
+                    <p:cond delay="indefinite"/>
+                  </p:stCondLst>
+                </p:cTn>
+                <p:tgtEl>
+                  <p:spTgt spid="3"/>
+                </p:tgtEl>
+              </p:cMediaNode>
+            </p:video>
+          </p:childTnLst>
+        </p:cTn>
+      </p:par>
+    </p:tnLst>
+  </p:timing>
 </p:sld>
 </file>
 
@@ -3438,7 +3319,7 @@
       <p:grpSpPr/>
       <p:pic>
         <p:nvPicPr>
-          <p:cNvPr id="2" name="Picture 1" descr="05-platform.png"/>
+          <p:cNvPr id="2" name="Picture 1" descr="05-why.png"/>
           <p:cNvPicPr>
             <a:picLocks noChangeAspect="1"/>
           </p:cNvPicPr>
@@ -3480,7 +3361,7 @@
       <p:grpSpPr/>
       <p:pic>
         <p:nvPicPr>
-          <p:cNvPr id="2" name="Picture 1" descr="06-forge.png"/>
+          <p:cNvPr id="2" name="Picture 1" descr="06-model.png"/>
           <p:cNvPicPr>
             <a:picLocks noChangeAspect="1"/>
           </p:cNvPicPr>
@@ -3522,91 +3403,7 @@
       <p:grpSpPr/>
       <p:pic>
         <p:nvPicPr>
-          <p:cNvPr id="2" name="Picture 1" descr="07-studio.png"/>
-          <p:cNvPicPr>
-            <a:picLocks noChangeAspect="1"/>
-          </p:cNvPicPr>
-          <p:nvPr/>
-        </p:nvPicPr>
-        <p:blipFill>
-          <a:blip r:embed="rId2"/>
-          <a:stretch>
-            <a:fillRect/>
-          </a:stretch>
-        </p:blipFill>
-        <p:spPr>
-          <a:xfrm>
-            <a:off x="0" y="0"/>
-            <a:ext cx="12192000" cy="6858000"/>
-          </a:xfrm>
-          <a:prstGeom prst="rect">
-            <a:avLst/>
-          </a:prstGeom>
-        </p:spPr>
-      </p:pic>
-    </p:spTree>
-  </p:cSld>
-  <p:clrMapOvr>
-    <a:masterClrMapping/>
-  </p:clrMapOvr>
-</p:sld>
-</file>
-
-<file path=ppt/slides/slide8.xml><?xml version="1.0" encoding="utf-8"?>
-<p:sld xmlns:a="http://schemas.openxmlformats.org/drawingml/2006/main" xmlns:p="http://schemas.openxmlformats.org/presentationml/2006/main" xmlns:r="http://schemas.openxmlformats.org/officeDocument/2006/relationships">
-  <p:cSld>
-    <p:spTree>
-      <p:nvGrpSpPr>
-        <p:cNvPr id="1" name=""/>
-        <p:cNvGrpSpPr/>
-        <p:nvPr/>
-      </p:nvGrpSpPr>
-      <p:grpSpPr/>
-      <p:pic>
-        <p:nvPicPr>
-          <p:cNvPr id="2" name="Picture 1" descr="08-archie.png"/>
-          <p:cNvPicPr>
-            <a:picLocks noChangeAspect="1"/>
-          </p:cNvPicPr>
-          <p:nvPr/>
-        </p:nvPicPr>
-        <p:blipFill>
-          <a:blip r:embed="rId2"/>
-          <a:stretch>
-            <a:fillRect/>
-          </a:stretch>
-        </p:blipFill>
-        <p:spPr>
-          <a:xfrm>
-            <a:off x="0" y="0"/>
-            <a:ext cx="12192000" cy="6858000"/>
-          </a:xfrm>
-          <a:prstGeom prst="rect">
-            <a:avLst/>
-          </a:prstGeom>
-        </p:spPr>
-      </p:pic>
-    </p:spTree>
-  </p:cSld>
-  <p:clrMapOvr>
-    <a:masterClrMapping/>
-  </p:clrMapOvr>
-</p:sld>
-</file>
-
-<file path=ppt/slides/slide9.xml><?xml version="1.0" encoding="utf-8"?>
-<p:sld xmlns:a="http://schemas.openxmlformats.org/drawingml/2006/main" xmlns:p="http://schemas.openxmlformats.org/presentationml/2006/main" xmlns:r="http://schemas.openxmlformats.org/officeDocument/2006/relationships">
-  <p:cSld>
-    <p:spTree>
-      <p:nvGrpSpPr>
-        <p:cNvPr id="1" name=""/>
-        <p:cNvGrpSpPr/>
-        <p:nvPr/>
-      </p:nvGrpSpPr>
-      <p:grpSpPr/>
-      <p:pic>
-        <p:nvPicPr>
-          <p:cNvPr id="2" name="Picture 1" descr="09-moats.png"/>
+          <p:cNvPr id="2" name="Picture 1" descr="07-ask.png"/>
           <p:cNvPicPr>
             <a:picLocks noChangeAspect="1"/>
           </p:cNvPicPr>

</xml_diff>